<commit_message>
Update billing dispute timeline with corrections
Update the metadata and PowerPoint file for the Replit billing dispute timeline to correct layout and content issues.

Replit-Commit-Author: Agent
Replit-Commit-Session-Id: 023c6d0a-693c-4441-9f2f-7ed8156545ee
Replit-Commit-Checkpoint-Type: full_checkpoint
Replit-Commit-Event-Id: 26944b12-be7a-4795-ba80-16cef0a6f67d
Replit-Commit-Screenshot-Url: https://storage.googleapis.com/screenshot-production-us-central1/a0c66905-cda9-4d99-8753-e071287d758d/023c6d0a-693c-4441-9f2f-7ed8156545ee/fRP92jR
Replit-Helium-Checkpoint-Created: true
</commit_message>
<xml_diff>
--- a/attached_assets/Replit_Billing_Dispute_Timeline.pptx
+++ b/attached_assets/Replit_Billing_Dispute_Timeline.pptx
@@ -4941,102 +4941,24 @@
       </p:sp>
       <p:sp>
         <p:nvSpPr>
-          <p:cNvPr id="100" name="Text 98"/>
+          <p:cNvPr id="100" name="Shape 98"/>
           <p:cNvSpPr/>
           <p:nvPr/>
         </p:nvSpPr>
         <p:spPr>
           <a:xfrm>
             <a:off x="274320" y="5971032"/>
-            <a:ext cx="3657600" cy="274320"/>
-          </a:xfrm>
-          <a:prstGeom prst="rect">
-            <a:avLst/>
-          </a:prstGeom>
-          <a:noFill/>
-          <a:ln/>
-        </p:spPr>
-        <p:txBody>
-          <a:bodyPr wrap="square" rtlCol="0" anchor="ctr"/>
-          <a:lstStyle/>
-          <a:p>
-            <a:pPr indent="0" marL="0">
-              <a:buNone/>
-            </a:pPr>
-            <a:r>
-              <a:rPr lang="en-US" sz="1300" b="1" dirty="0">
-                <a:solidFill>
-                  <a:srgbClr val="0E2C66"/>
-                </a:solidFill>
-                <a:latin typeface="Calibri" pitchFamily="34" charset="0"/>
-                <a:ea typeface="Calibri" pitchFamily="34" charset="-122"/>
-                <a:cs typeface="Calibri" pitchFamily="34" charset="-120"/>
-              </a:rPr>
-              <a:t>ONGOING EVIDENCE</a:t>
-            </a:r>
-            <a:endParaRPr lang="en-US" sz="1300" dirty="0"/>
-          </a:p>
-        </p:txBody>
-      </p:sp>
-      <p:sp>
-        <p:nvSpPr>
-          <p:cNvPr id="101" name="Text 99"/>
-          <p:cNvSpPr/>
-          <p:nvPr/>
-        </p:nvSpPr>
-        <p:spPr>
-          <a:xfrm>
-            <a:off x="3931920" y="5971032"/>
-            <a:ext cx="8229600" cy="274320"/>
-          </a:xfrm>
-          <a:prstGeom prst="rect">
-            <a:avLst/>
-          </a:prstGeom>
-          <a:noFill/>
-          <a:ln/>
-        </p:spPr>
-        <p:txBody>
-          <a:bodyPr wrap="square" rtlCol="0" anchor="ctr"/>
-          <a:lstStyle/>
-          <a:p>
-            <a:pPr indent="0" marL="0">
-              <a:buNone/>
-            </a:pPr>
-            <a:r>
-              <a:rPr lang="en-US" sz="1000" i="1" dirty="0">
-                <a:solidFill>
-                  <a:srgbClr val="4B5563"/>
-                </a:solidFill>
-                <a:latin typeface="Calibri" pitchFamily="34" charset="0"/>
-                <a:ea typeface="Calibri" pitchFamily="34" charset="-122"/>
-                <a:cs typeface="Calibri" pitchFamily="34" charset="-120"/>
-              </a:rPr>
-              <a:t>(From SS History1.pdf, Other Screenshots, and Project Loss 1–51.png)</a:t>
-            </a:r>
-            <a:endParaRPr lang="en-US" sz="1000" dirty="0"/>
-          </a:p>
-        </p:txBody>
-      </p:sp>
-      <p:sp>
-        <p:nvSpPr>
-          <p:cNvPr id="102" name="Shape 100"/>
-          <p:cNvSpPr/>
-          <p:nvPr/>
-        </p:nvSpPr>
-        <p:spPr>
-          <a:xfrm>
-            <a:off x="274320" y="6300216"/>
-            <a:ext cx="2133600" cy="777240"/>
-          </a:xfrm>
-          <a:prstGeom prst="rect">
-            <a:avLst/>
-          </a:prstGeom>
-          <a:solidFill>
-            <a:srgbClr val="FFFFFF"/>
+            <a:ext cx="12344400" cy="292608"/>
+          </a:xfrm>
+          <a:prstGeom prst="rect">
+            <a:avLst/>
+          </a:prstGeom>
+          <a:solidFill>
+            <a:srgbClr val="0E2C66"/>
           </a:solidFill>
           <a:ln w="12700">
             <a:solidFill>
-              <a:srgbClr val="94A3B8"/>
+              <a:srgbClr val="0E2C66"/>
             </a:solidFill>
             <a:prstDash val="solid"/>
           </a:ln>
@@ -5044,14 +4966,14 @@
       </p:sp>
       <p:sp>
         <p:nvSpPr>
-          <p:cNvPr id="103" name="Text 101"/>
-          <p:cNvSpPr/>
-          <p:nvPr/>
-        </p:nvSpPr>
-        <p:spPr>
-          <a:xfrm>
-            <a:off x="347472" y="6355080"/>
-            <a:ext cx="1987296" cy="667512"/>
+          <p:cNvPr id="101" name="Text 99"/>
+          <p:cNvSpPr/>
+          <p:nvPr/>
+        </p:nvSpPr>
+        <p:spPr>
+          <a:xfrm>
+            <a:off x="411480" y="5971032"/>
+            <a:ext cx="12161520" cy="292608"/>
           </a:xfrm>
           <a:prstGeom prst="rect">
             <a:avLst/>
@@ -5063,44 +4985,58 @@
           <a:bodyPr wrap="square" rtlCol="0" anchor="ctr"/>
           <a:lstStyle/>
           <a:p>
-            <a:pPr algn="ctr" indent="0" marL="0">
-              <a:buNone/>
-            </a:pPr>
-            <a:r>
-              <a:rPr lang="en-US" sz="800" dirty="0">
-                <a:solidFill>
-                  <a:srgbClr val="111827"/>
-                </a:solidFill>
-                <a:latin typeface="Calibri" pitchFamily="34" charset="0"/>
-                <a:ea typeface="Calibri" pitchFamily="34" charset="-122"/>
-                <a:cs typeface="Calibri" pitchFamily="34" charset="-120"/>
-              </a:rPr>
-              <a:t>Agent admits repeated loops and going "in circles"</a:t>
-            </a:r>
-            <a:endParaRPr lang="en-US" sz="800" dirty="0"/>
-          </a:p>
-        </p:txBody>
-      </p:sp>
-      <p:sp>
-        <p:nvSpPr>
-          <p:cNvPr id="104" name="Shape 102"/>
-          <p:cNvSpPr/>
-          <p:nvPr/>
-        </p:nvSpPr>
-        <p:spPr>
-          <a:xfrm>
-            <a:off x="2499360" y="6300216"/>
-            <a:ext cx="2133600" cy="777240"/>
-          </a:xfrm>
-          <a:prstGeom prst="rect">
+            <a:pPr algn="l" indent="0" marL="0">
+              <a:buNone/>
+            </a:pPr>
+            <a:r>
+              <a:rPr lang="en-US" sz="1100" b="1" dirty="0">
+                <a:solidFill>
+                  <a:srgbClr val="FFFFFF"/>
+                </a:solidFill>
+                <a:latin typeface="Calibri" pitchFamily="34" charset="0"/>
+                <a:ea typeface="Calibri" pitchFamily="34" charset="-122"/>
+                <a:cs typeface="Calibri" pitchFamily="34" charset="-120"/>
+              </a:rPr>
+              <a:t>ONGOING EVIDENCE  </a:t>
+            </a:r>
+            <a:pPr algn="l" indent="0" marL="0">
+              <a:buNone/>
+            </a:pPr>
+            <a:r>
+              <a:rPr lang="en-US" sz="900" i="1" dirty="0">
+                <a:solidFill>
+                  <a:srgbClr val="E5E7EB"/>
+                </a:solidFill>
+                <a:latin typeface="Calibri" pitchFamily="34" charset="0"/>
+                <a:ea typeface="Calibri" pitchFamily="34" charset="-122"/>
+                <a:cs typeface="Calibri" pitchFamily="34" charset="-120"/>
+              </a:rPr>
+              <a:t>(From SS History1.pdf, Other Screenshots, and Project Loss 1–51.png)</a:t>
+            </a:r>
+            <a:endParaRPr lang="en-US" sz="1100" dirty="0"/>
+          </a:p>
+        </p:txBody>
+      </p:sp>
+      <p:sp>
+        <p:nvSpPr>
+          <p:cNvPr id="102" name="Shape 100"/>
+          <p:cNvSpPr/>
+          <p:nvPr/>
+        </p:nvSpPr>
+        <p:spPr>
+          <a:xfrm>
+            <a:off x="1139952" y="6318504"/>
+            <a:ext cx="402336" cy="402336"/>
+          </a:xfrm>
+          <a:prstGeom prst="ellipse">
             <a:avLst/>
           </a:prstGeom>
           <a:solidFill>
             <a:srgbClr val="FFFFFF"/>
           </a:solidFill>
-          <a:ln w="12700">
+          <a:ln w="25400">
             <a:solidFill>
-              <a:srgbClr val="94A3B8"/>
+              <a:srgbClr val="16A34A"/>
             </a:solidFill>
             <a:prstDash val="solid"/>
           </a:ln>
@@ -5108,14 +5044,14 @@
       </p:sp>
       <p:sp>
         <p:nvSpPr>
-          <p:cNvPr id="105" name="Text 103"/>
-          <p:cNvSpPr/>
-          <p:nvPr/>
-        </p:nvSpPr>
-        <p:spPr>
-          <a:xfrm>
-            <a:off x="2572512" y="6355080"/>
-            <a:ext cx="1987296" cy="667512"/>
+          <p:cNvPr id="103" name="Text 101"/>
+          <p:cNvSpPr/>
+          <p:nvPr/>
+        </p:nvSpPr>
+        <p:spPr>
+          <a:xfrm>
+            <a:off x="1139952" y="6318504"/>
+            <a:ext cx="402336" cy="402336"/>
           </a:xfrm>
           <a:prstGeom prst="rect">
             <a:avLst/>
@@ -5131,6 +5067,45 @@
               <a:buNone/>
             </a:pPr>
             <a:r>
+              <a:rPr lang="en-US" sz="1800" b="1" dirty="0">
+                <a:solidFill>
+                  <a:srgbClr val="16A34A"/>
+                </a:solidFill>
+                <a:latin typeface="Calibri" pitchFamily="34" charset="0"/>
+                <a:ea typeface="Calibri" pitchFamily="34" charset="-122"/>
+                <a:cs typeface="Calibri" pitchFamily="34" charset="-120"/>
+              </a:rPr>
+              <a:t>⟳</a:t>
+            </a:r>
+            <a:endParaRPr lang="en-US" sz="1800" dirty="0"/>
+          </a:p>
+        </p:txBody>
+      </p:sp>
+      <p:sp>
+        <p:nvSpPr>
+          <p:cNvPr id="104" name="Text 102"/>
+          <p:cNvSpPr/>
+          <p:nvPr/>
+        </p:nvSpPr>
+        <p:spPr>
+          <a:xfrm>
+            <a:off x="356616" y="6757416"/>
+            <a:ext cx="1969008" cy="502920"/>
+          </a:xfrm>
+          <a:prstGeom prst="rect">
+            <a:avLst/>
+          </a:prstGeom>
+          <a:noFill/>
+          <a:ln/>
+        </p:spPr>
+        <p:txBody>
+          <a:bodyPr wrap="square" rtlCol="0" anchor="t"/>
+          <a:lstStyle/>
+          <a:p>
+            <a:pPr algn="ctr" indent="0" marL="0">
+              <a:buNone/>
+            </a:pPr>
+            <a:r>
               <a:rPr lang="en-US" sz="800" dirty="0">
                 <a:solidFill>
                   <a:srgbClr val="111827"/>
@@ -5139,7 +5114,7 @@
                 <a:ea typeface="Calibri" pitchFamily="34" charset="-122"/>
                 <a:cs typeface="Calibri" pitchFamily="34" charset="-120"/>
               </a:rPr>
-              <a:t>Agent admits ignoring instructions</a:t>
+              <a:t>Agent admits repeated loops and going "in circles"</a:t>
             </a:r>
             <a:endParaRPr lang="en-US" sz="800" dirty="0"/>
           </a:p>
@@ -5147,24 +5122,24 @@
       </p:sp>
       <p:sp>
         <p:nvSpPr>
-          <p:cNvPr id="106" name="Shape 104"/>
-          <p:cNvSpPr/>
-          <p:nvPr/>
-        </p:nvSpPr>
-        <p:spPr>
-          <a:xfrm>
-            <a:off x="4724400" y="6300216"/>
-            <a:ext cx="2133600" cy="777240"/>
-          </a:xfrm>
-          <a:prstGeom prst="rect">
+          <p:cNvPr id="105" name="Shape 103"/>
+          <p:cNvSpPr/>
+          <p:nvPr/>
+        </p:nvSpPr>
+        <p:spPr>
+          <a:xfrm>
+            <a:off x="3182112" y="6318504"/>
+            <a:ext cx="402336" cy="402336"/>
+          </a:xfrm>
+          <a:prstGeom prst="ellipse">
             <a:avLst/>
           </a:prstGeom>
           <a:solidFill>
             <a:srgbClr val="FFFFFF"/>
           </a:solidFill>
-          <a:ln w="12700">
+          <a:ln w="25400">
             <a:solidFill>
-              <a:srgbClr val="94A3B8"/>
+              <a:srgbClr val="F59E0B"/>
             </a:solidFill>
             <a:prstDash val="solid"/>
           </a:ln>
@@ -5172,23 +5147,62 @@
       </p:sp>
       <p:sp>
         <p:nvSpPr>
+          <p:cNvPr id="106" name="Text 104"/>
+          <p:cNvSpPr/>
+          <p:nvPr/>
+        </p:nvSpPr>
+        <p:spPr>
+          <a:xfrm>
+            <a:off x="3182112" y="6318504"/>
+            <a:ext cx="402336" cy="402336"/>
+          </a:xfrm>
+          <a:prstGeom prst="rect">
+            <a:avLst/>
+          </a:prstGeom>
+          <a:noFill/>
+          <a:ln/>
+        </p:spPr>
+        <p:txBody>
+          <a:bodyPr wrap="square" rtlCol="0" anchor="ctr"/>
+          <a:lstStyle/>
+          <a:p>
+            <a:pPr algn="ctr" indent="0" marL="0">
+              <a:buNone/>
+            </a:pPr>
+            <a:r>
+              <a:rPr lang="en-US" sz="1800" b="1" dirty="0">
+                <a:solidFill>
+                  <a:srgbClr val="F59E0B"/>
+                </a:solidFill>
+                <a:latin typeface="Calibri" pitchFamily="34" charset="0"/>
+                <a:ea typeface="Calibri" pitchFamily="34" charset="-122"/>
+                <a:cs typeface="Calibri" pitchFamily="34" charset="-120"/>
+              </a:rPr>
+              <a:t>⚠</a:t>
+            </a:r>
+            <a:endParaRPr lang="en-US" sz="1800" dirty="0"/>
+          </a:p>
+        </p:txBody>
+      </p:sp>
+      <p:sp>
+        <p:nvSpPr>
           <p:cNvPr id="107" name="Text 105"/>
           <p:cNvSpPr/>
           <p:nvPr/>
         </p:nvSpPr>
         <p:spPr>
           <a:xfrm>
-            <a:off x="4797552" y="6355080"/>
-            <a:ext cx="1987296" cy="667512"/>
-          </a:xfrm>
-          <a:prstGeom prst="rect">
-            <a:avLst/>
-          </a:prstGeom>
-          <a:noFill/>
-          <a:ln/>
-        </p:spPr>
-        <p:txBody>
-          <a:bodyPr wrap="square" rtlCol="0" anchor="ctr"/>
+            <a:off x="2398776" y="6757416"/>
+            <a:ext cx="1969008" cy="502920"/>
+          </a:xfrm>
+          <a:prstGeom prst="rect">
+            <a:avLst/>
+          </a:prstGeom>
+          <a:noFill/>
+          <a:ln/>
+        </p:spPr>
+        <p:txBody>
+          <a:bodyPr wrap="square" rtlCol="0" anchor="t"/>
           <a:lstStyle/>
           <a:p>
             <a:pPr algn="ctr" indent="0" marL="0">
@@ -5203,7 +5217,7 @@
                 <a:ea typeface="Calibri" pitchFamily="34" charset="-122"/>
                 <a:cs typeface="Calibri" pitchFamily="34" charset="-120"/>
               </a:rPr>
-              <a:t>Agent admits false "pushed" confirmations (work not actually deployed)</a:t>
+              <a:t>Agent admits ignoring instructions</a:t>
             </a:r>
             <a:endParaRPr lang="en-US" sz="800" dirty="0"/>
           </a:p>
@@ -5217,18 +5231,18 @@
         </p:nvSpPr>
         <p:spPr>
           <a:xfrm>
-            <a:off x="6949440" y="6300216"/>
-            <a:ext cx="2133600" cy="777240"/>
-          </a:xfrm>
-          <a:prstGeom prst="rect">
+            <a:off x="5224272" y="6318504"/>
+            <a:ext cx="402336" cy="402336"/>
+          </a:xfrm>
+          <a:prstGeom prst="ellipse">
             <a:avLst/>
           </a:prstGeom>
           <a:solidFill>
             <a:srgbClr val="FFFFFF"/>
           </a:solidFill>
-          <a:ln w="12700">
+          <a:ln w="25400">
             <a:solidFill>
-              <a:srgbClr val="94A3B8"/>
+              <a:srgbClr val="2563EB"/>
             </a:solidFill>
             <a:prstDash val="solid"/>
           </a:ln>
@@ -5242,8 +5256,8 @@
         </p:nvSpPr>
         <p:spPr>
           <a:xfrm>
-            <a:off x="7022592" y="6355080"/>
-            <a:ext cx="1987296" cy="667512"/>
+            <a:off x="5224272" y="6318504"/>
+            <a:ext cx="402336" cy="402336"/>
           </a:xfrm>
           <a:prstGeom prst="rect">
             <a:avLst/>
@@ -5259,6 +5273,45 @@
               <a:buNone/>
             </a:pPr>
             <a:r>
+              <a:rPr lang="en-US" sz="1800" b="1" dirty="0">
+                <a:solidFill>
+                  <a:srgbClr val="2563EB"/>
+                </a:solidFill>
+                <a:latin typeface="Calibri" pitchFamily="34" charset="0"/>
+                <a:ea typeface="Calibri" pitchFamily="34" charset="-122"/>
+                <a:cs typeface="Calibri" pitchFamily="34" charset="-120"/>
+              </a:rPr>
+              <a:t>☑</a:t>
+            </a:r>
+            <a:endParaRPr lang="en-US" sz="1800" dirty="0"/>
+          </a:p>
+        </p:txBody>
+      </p:sp>
+      <p:sp>
+        <p:nvSpPr>
+          <p:cNvPr id="110" name="Text 108"/>
+          <p:cNvSpPr/>
+          <p:nvPr/>
+        </p:nvSpPr>
+        <p:spPr>
+          <a:xfrm>
+            <a:off x="4440936" y="6757416"/>
+            <a:ext cx="1969008" cy="502920"/>
+          </a:xfrm>
+          <a:prstGeom prst="rect">
+            <a:avLst/>
+          </a:prstGeom>
+          <a:noFill/>
+          <a:ln/>
+        </p:spPr>
+        <p:txBody>
+          <a:bodyPr wrap="square" rtlCol="0" anchor="t"/>
+          <a:lstStyle/>
+          <a:p>
+            <a:pPr algn="ctr" indent="0" marL="0">
+              <a:buNone/>
+            </a:pPr>
+            <a:r>
               <a:rPr lang="en-US" sz="800" dirty="0">
                 <a:solidFill>
                   <a:srgbClr val="111827"/>
@@ -5267,7 +5320,7 @@
                 <a:ea typeface="Calibri" pitchFamily="34" charset="-122"/>
                 <a:cs typeface="Calibri" pitchFamily="34" charset="-120"/>
               </a:rPr>
-              <a:t>Agent admits repeatedly doing the same work multiple times</a:t>
+              <a:t>Agent admits false "pushed" confirmations (work not actually deployed)</a:t>
             </a:r>
             <a:endParaRPr lang="en-US" sz="800" dirty="0"/>
           </a:p>
@@ -5275,24 +5328,24 @@
       </p:sp>
       <p:sp>
         <p:nvSpPr>
-          <p:cNvPr id="110" name="Shape 108"/>
-          <p:cNvSpPr/>
-          <p:nvPr/>
-        </p:nvSpPr>
-        <p:spPr>
-          <a:xfrm>
-            <a:off x="9174480" y="6300216"/>
-            <a:ext cx="2133600" cy="777240"/>
-          </a:xfrm>
-          <a:prstGeom prst="rect">
+          <p:cNvPr id="111" name="Shape 109"/>
+          <p:cNvSpPr/>
+          <p:nvPr/>
+        </p:nvSpPr>
+        <p:spPr>
+          <a:xfrm>
+            <a:off x="7266432" y="6318504"/>
+            <a:ext cx="402336" cy="402336"/>
+          </a:xfrm>
+          <a:prstGeom prst="ellipse">
             <a:avLst/>
           </a:prstGeom>
           <a:solidFill>
             <a:srgbClr val="FFFFFF"/>
           </a:solidFill>
-          <a:ln w="12700">
+          <a:ln w="25400">
             <a:solidFill>
-              <a:srgbClr val="94A3B8"/>
+              <a:srgbClr val="16A34A"/>
             </a:solidFill>
             <a:prstDash val="solid"/>
           </a:ln>
@@ -5300,14 +5353,14 @@
       </p:sp>
       <p:sp>
         <p:nvSpPr>
-          <p:cNvPr id="111" name="Text 109"/>
-          <p:cNvSpPr/>
-          <p:nvPr/>
-        </p:nvSpPr>
-        <p:spPr>
-          <a:xfrm>
-            <a:off x="9247632" y="6355080"/>
-            <a:ext cx="1987296" cy="667512"/>
+          <p:cNvPr id="112" name="Text 110"/>
+          <p:cNvSpPr/>
+          <p:nvPr/>
+        </p:nvSpPr>
+        <p:spPr>
+          <a:xfrm>
+            <a:off x="7266432" y="6318504"/>
+            <a:ext cx="402336" cy="402336"/>
           </a:xfrm>
           <a:prstGeom prst="rect">
             <a:avLst/>
@@ -5323,6 +5376,45 @@
               <a:buNone/>
             </a:pPr>
             <a:r>
+              <a:rPr lang="en-US" sz="1800" b="1" dirty="0">
+                <a:solidFill>
+                  <a:srgbClr val="16A34A"/>
+                </a:solidFill>
+                <a:latin typeface="Calibri" pitchFamily="34" charset="0"/>
+                <a:ea typeface="Calibri" pitchFamily="34" charset="-122"/>
+                <a:cs typeface="Calibri" pitchFamily="34" charset="-120"/>
+              </a:rPr>
+              <a:t>⟳</a:t>
+            </a:r>
+            <a:endParaRPr lang="en-US" sz="1800" dirty="0"/>
+          </a:p>
+        </p:txBody>
+      </p:sp>
+      <p:sp>
+        <p:nvSpPr>
+          <p:cNvPr id="113" name="Text 111"/>
+          <p:cNvSpPr/>
+          <p:nvPr/>
+        </p:nvSpPr>
+        <p:spPr>
+          <a:xfrm>
+            <a:off x="6483096" y="6757416"/>
+            <a:ext cx="1969008" cy="502920"/>
+          </a:xfrm>
+          <a:prstGeom prst="rect">
+            <a:avLst/>
+          </a:prstGeom>
+          <a:noFill/>
+          <a:ln/>
+        </p:spPr>
+        <p:txBody>
+          <a:bodyPr wrap="square" rtlCol="0" anchor="t"/>
+          <a:lstStyle/>
+          <a:p>
+            <a:pPr algn="ctr" indent="0" marL="0">
+              <a:buNone/>
+            </a:pPr>
+            <a:r>
               <a:rPr lang="en-US" sz="800" dirty="0">
                 <a:solidFill>
                   <a:srgbClr val="111827"/>
@@ -5331,7 +5423,7 @@
                 <a:ea typeface="Calibri" pitchFamily="34" charset="-122"/>
                 <a:cs typeface="Calibri" pitchFamily="34" charset="-120"/>
               </a:rPr>
-              <a:t>System loses context and forgets prior conversations</a:t>
+              <a:t>Agent admits repeatedly doing the same work multiple times</a:t>
             </a:r>
             <a:endParaRPr lang="en-US" sz="800" dirty="0"/>
           </a:p>
@@ -5339,24 +5431,24 @@
       </p:sp>
       <p:sp>
         <p:nvSpPr>
-          <p:cNvPr id="112" name="Shape 110"/>
-          <p:cNvSpPr/>
-          <p:nvPr/>
-        </p:nvSpPr>
-        <p:spPr>
-          <a:xfrm>
-            <a:off x="11399520" y="6300216"/>
-            <a:ext cx="2133600" cy="777240"/>
-          </a:xfrm>
-          <a:prstGeom prst="rect">
+          <p:cNvPr id="114" name="Shape 112"/>
+          <p:cNvSpPr/>
+          <p:nvPr/>
+        </p:nvSpPr>
+        <p:spPr>
+          <a:xfrm>
+            <a:off x="9308592" y="6318504"/>
+            <a:ext cx="402336" cy="402336"/>
+          </a:xfrm>
+          <a:prstGeom prst="ellipse">
             <a:avLst/>
           </a:prstGeom>
           <a:solidFill>
             <a:srgbClr val="FFFFFF"/>
           </a:solidFill>
-          <a:ln w="12700">
+          <a:ln w="25400">
             <a:solidFill>
-              <a:srgbClr val="94A3B8"/>
+              <a:srgbClr val="EA580C"/>
             </a:solidFill>
             <a:prstDash val="solid"/>
           </a:ln>
@@ -5364,14 +5456,14 @@
       </p:sp>
       <p:sp>
         <p:nvSpPr>
-          <p:cNvPr id="113" name="Text 111"/>
-          <p:cNvSpPr/>
-          <p:nvPr/>
-        </p:nvSpPr>
-        <p:spPr>
-          <a:xfrm>
-            <a:off x="11472672" y="6355080"/>
-            <a:ext cx="1987296" cy="667512"/>
+          <p:cNvPr id="115" name="Text 113"/>
+          <p:cNvSpPr/>
+          <p:nvPr/>
+        </p:nvSpPr>
+        <p:spPr>
+          <a:xfrm>
+            <a:off x="9308592" y="6318504"/>
+            <a:ext cx="402336" cy="402336"/>
           </a:xfrm>
           <a:prstGeom prst="rect">
             <a:avLst/>
@@ -5387,6 +5479,45 @@
               <a:buNone/>
             </a:pPr>
             <a:r>
+              <a:rPr lang="en-US" sz="1800" b="1" dirty="0">
+                <a:solidFill>
+                  <a:srgbClr val="EA580C"/>
+                </a:solidFill>
+                <a:latin typeface="Calibri" pitchFamily="34" charset="0"/>
+                <a:ea typeface="Calibri" pitchFamily="34" charset="-122"/>
+                <a:cs typeface="Calibri" pitchFamily="34" charset="-120"/>
+              </a:rPr>
+              <a:t>⟲</a:t>
+            </a:r>
+            <a:endParaRPr lang="en-US" sz="1800" dirty="0"/>
+          </a:p>
+        </p:txBody>
+      </p:sp>
+      <p:sp>
+        <p:nvSpPr>
+          <p:cNvPr id="116" name="Text 114"/>
+          <p:cNvSpPr/>
+          <p:nvPr/>
+        </p:nvSpPr>
+        <p:spPr>
+          <a:xfrm>
+            <a:off x="8525256" y="6757416"/>
+            <a:ext cx="1969008" cy="502920"/>
+          </a:xfrm>
+          <a:prstGeom prst="rect">
+            <a:avLst/>
+          </a:prstGeom>
+          <a:noFill/>
+          <a:ln/>
+        </p:spPr>
+        <p:txBody>
+          <a:bodyPr wrap="square" rtlCol="0" anchor="t"/>
+          <a:lstStyle/>
+          <a:p>
+            <a:pPr algn="ctr" indent="0" marL="0">
+              <a:buNone/>
+            </a:pPr>
+            <a:r>
               <a:rPr lang="en-US" sz="800" dirty="0">
                 <a:solidFill>
                   <a:srgbClr val="111827"/>
@@ -5395,7 +5526,7 @@
                 <a:ea typeface="Calibri" pitchFamily="34" charset="-122"/>
                 <a:cs typeface="Calibri" pitchFamily="34" charset="-120"/>
               </a:rPr>
-              <a:t>All of the above resulted in wasted time and excessive billable usage</a:t>
+              <a:t>System loses context and forgets prior conversations</a:t>
             </a:r>
             <a:endParaRPr lang="en-US" sz="800" dirty="0"/>
           </a:p>
@@ -5403,24 +5534,24 @@
       </p:sp>
       <p:sp>
         <p:nvSpPr>
-          <p:cNvPr id="114" name="Shape 112"/>
-          <p:cNvSpPr/>
-          <p:nvPr/>
-        </p:nvSpPr>
-        <p:spPr>
-          <a:xfrm>
-            <a:off x="13716000" y="6300216"/>
-            <a:ext cx="1417320" cy="365760"/>
-          </a:xfrm>
-          <a:prstGeom prst="rect">
-            <a:avLst/>
-          </a:prstGeom>
-          <a:solidFill>
-            <a:srgbClr val="B91C1C"/>
-          </a:solidFill>
-          <a:ln w="12700">
+          <p:cNvPr id="117" name="Shape 115"/>
+          <p:cNvSpPr/>
+          <p:nvPr/>
+        </p:nvSpPr>
+        <p:spPr>
+          <a:xfrm>
+            <a:off x="11350752" y="6318504"/>
+            <a:ext cx="402336" cy="402336"/>
+          </a:xfrm>
+          <a:prstGeom prst="ellipse">
+            <a:avLst/>
+          </a:prstGeom>
+          <a:solidFill>
+            <a:srgbClr val="FFFFFF"/>
+          </a:solidFill>
+          <a:ln w="25400">
             <a:solidFill>
-              <a:srgbClr val="B91C1C"/>
+              <a:srgbClr val="7C3AED"/>
             </a:solidFill>
             <a:prstDash val="solid"/>
           </a:ln>
@@ -5428,14 +5559,14 @@
       </p:sp>
       <p:sp>
         <p:nvSpPr>
-          <p:cNvPr id="115" name="Text 113"/>
-          <p:cNvSpPr/>
-          <p:nvPr/>
-        </p:nvSpPr>
-        <p:spPr>
-          <a:xfrm>
-            <a:off x="13716000" y="6300216"/>
-            <a:ext cx="1417320" cy="365760"/>
+          <p:cNvPr id="118" name="Text 116"/>
+          <p:cNvSpPr/>
+          <p:nvPr/>
+        </p:nvSpPr>
+        <p:spPr>
+          <a:xfrm>
+            <a:off x="11350752" y="6318504"/>
+            <a:ext cx="402336" cy="402336"/>
           </a:xfrm>
           <a:prstGeom prst="rect">
             <a:avLst/>
@@ -5451,40 +5582,79 @@
               <a:buNone/>
             </a:pPr>
             <a:r>
-              <a:rPr lang="en-US" sz="900" b="1" dirty="0">
-                <a:solidFill>
-                  <a:srgbClr val="FFFFFF"/>
-                </a:solidFill>
-                <a:latin typeface="Calibri" pitchFamily="34" charset="0"/>
-                <a:ea typeface="Calibri" pitchFamily="34" charset="-122"/>
-                <a:cs typeface="Calibri" pitchFamily="34" charset="-120"/>
-              </a:rPr>
-              <a:t>TECHNICAL FAILURE</a:t>
-            </a:r>
-            <a:endParaRPr lang="en-US" sz="900" dirty="0"/>
-          </a:p>
-        </p:txBody>
-      </p:sp>
-      <p:sp>
-        <p:nvSpPr>
-          <p:cNvPr id="116" name="Shape 114"/>
-          <p:cNvSpPr/>
-          <p:nvPr/>
-        </p:nvSpPr>
-        <p:spPr>
-          <a:xfrm>
-            <a:off x="13716000" y="6711696"/>
-            <a:ext cx="1417320" cy="365760"/>
-          </a:xfrm>
-          <a:prstGeom prst="rect">
-            <a:avLst/>
-          </a:prstGeom>
-          <a:solidFill>
-            <a:srgbClr val="6D28D9"/>
-          </a:solidFill>
-          <a:ln w="12700">
+              <a:rPr lang="en-US" sz="1800" b="1" dirty="0">
+                <a:solidFill>
+                  <a:srgbClr val="7C3AED"/>
+                </a:solidFill>
+                <a:latin typeface="Calibri" pitchFamily="34" charset="0"/>
+                <a:ea typeface="Calibri" pitchFamily="34" charset="-122"/>
+                <a:cs typeface="Calibri" pitchFamily="34" charset="-120"/>
+              </a:rPr>
+              <a:t>✦</a:t>
+            </a:r>
+            <a:endParaRPr lang="en-US" sz="1800" dirty="0"/>
+          </a:p>
+        </p:txBody>
+      </p:sp>
+      <p:sp>
+        <p:nvSpPr>
+          <p:cNvPr id="119" name="Text 117"/>
+          <p:cNvSpPr/>
+          <p:nvPr/>
+        </p:nvSpPr>
+        <p:spPr>
+          <a:xfrm>
+            <a:off x="10567416" y="6757416"/>
+            <a:ext cx="1969008" cy="502920"/>
+          </a:xfrm>
+          <a:prstGeom prst="rect">
+            <a:avLst/>
+          </a:prstGeom>
+          <a:noFill/>
+          <a:ln/>
+        </p:spPr>
+        <p:txBody>
+          <a:bodyPr wrap="square" rtlCol="0" anchor="t"/>
+          <a:lstStyle/>
+          <a:p>
+            <a:pPr algn="ctr" indent="0" marL="0">
+              <a:buNone/>
+            </a:pPr>
+            <a:r>
+              <a:rPr lang="en-US" sz="800" dirty="0">
+                <a:solidFill>
+                  <a:srgbClr val="111827"/>
+                </a:solidFill>
+                <a:latin typeface="Calibri" pitchFamily="34" charset="0"/>
+                <a:ea typeface="Calibri" pitchFamily="34" charset="-122"/>
+                <a:cs typeface="Calibri" pitchFamily="34" charset="-120"/>
+              </a:rPr>
+              <a:t>All of the above resulted in wasted time and excessive billable usage</a:t>
+            </a:r>
+            <a:endParaRPr lang="en-US" sz="800" dirty="0"/>
+          </a:p>
+        </p:txBody>
+      </p:sp>
+      <p:sp>
+        <p:nvSpPr>
+          <p:cNvPr id="120" name="Shape 118"/>
+          <p:cNvSpPr/>
+          <p:nvPr/>
+        </p:nvSpPr>
+        <p:spPr>
+          <a:xfrm>
+            <a:off x="12618720" y="6318504"/>
+            <a:ext cx="1417320" cy="457200"/>
+          </a:xfrm>
+          <a:prstGeom prst="rect">
+            <a:avLst/>
+          </a:prstGeom>
+          <a:solidFill>
+            <a:srgbClr val="B91C1C"/>
+          </a:solidFill>
+          <a:ln w="19050">
             <a:solidFill>
-              <a:srgbClr val="6D28D9"/>
+              <a:srgbClr val="7F1D1D"/>
             </a:solidFill>
             <a:prstDash val="solid"/>
           </a:ln>
@@ -5492,14 +5662,14 @@
       </p:sp>
       <p:sp>
         <p:nvSpPr>
-          <p:cNvPr id="117" name="Text 115"/>
-          <p:cNvSpPr/>
-          <p:nvPr/>
-        </p:nvSpPr>
-        <p:spPr>
-          <a:xfrm>
-            <a:off x="13716000" y="6711696"/>
-            <a:ext cx="1417320" cy="365760"/>
+          <p:cNvPr id="121" name="Text 119"/>
+          <p:cNvSpPr/>
+          <p:nvPr/>
+        </p:nvSpPr>
+        <p:spPr>
+          <a:xfrm>
+            <a:off x="12618720" y="6318504"/>
+            <a:ext cx="1417320" cy="457200"/>
           </a:xfrm>
           <a:prstGeom prst="rect">
             <a:avLst/>
@@ -5515,6 +5685,70 @@
               <a:buNone/>
             </a:pPr>
             <a:r>
+              <a:rPr lang="en-US" sz="1000" b="1" dirty="0">
+                <a:solidFill>
+                  <a:srgbClr val="FFFFFF"/>
+                </a:solidFill>
+                <a:latin typeface="Calibri" pitchFamily="34" charset="0"/>
+                <a:ea typeface="Calibri" pitchFamily="34" charset="-122"/>
+                <a:cs typeface="Calibri" pitchFamily="34" charset="-120"/>
+              </a:rPr>
+              <a:t>TECHNICAL FAILURE</a:t>
+            </a:r>
+            <a:endParaRPr lang="en-US" sz="1000" dirty="0"/>
+          </a:p>
+        </p:txBody>
+      </p:sp>
+      <p:sp>
+        <p:nvSpPr>
+          <p:cNvPr id="122" name="Shape 120"/>
+          <p:cNvSpPr/>
+          <p:nvPr/>
+        </p:nvSpPr>
+        <p:spPr>
+          <a:xfrm>
+            <a:off x="12618720" y="6821424"/>
+            <a:ext cx="1417320" cy="457200"/>
+          </a:xfrm>
+          <a:prstGeom prst="rect">
+            <a:avLst/>
+          </a:prstGeom>
+          <a:solidFill>
+            <a:srgbClr val="6D28D9"/>
+          </a:solidFill>
+          <a:ln w="19050">
+            <a:solidFill>
+              <a:srgbClr val="4C1D95"/>
+            </a:solidFill>
+            <a:prstDash val="solid"/>
+          </a:ln>
+        </p:spPr>
+      </p:sp>
+      <p:sp>
+        <p:nvSpPr>
+          <p:cNvPr id="123" name="Text 121"/>
+          <p:cNvSpPr/>
+          <p:nvPr/>
+        </p:nvSpPr>
+        <p:spPr>
+          <a:xfrm>
+            <a:off x="12618720" y="6821424"/>
+            <a:ext cx="1417320" cy="457200"/>
+          </a:xfrm>
+          <a:prstGeom prst="rect">
+            <a:avLst/>
+          </a:prstGeom>
+          <a:noFill/>
+          <a:ln/>
+        </p:spPr>
+        <p:txBody>
+          <a:bodyPr wrap="square" rtlCol="0" anchor="ctr"/>
+          <a:lstStyle/>
+          <a:p>
+            <a:pPr algn="ctr" indent="0" marL="0">
+              <a:buNone/>
+            </a:pPr>
+            <a:r>
               <a:rPr lang="en-US" sz="900" b="1" dirty="0">
                 <a:solidFill>
                   <a:srgbClr val="FFFFFF"/>
@@ -5531,14 +5765,14 @@
       </p:sp>
       <p:sp>
         <p:nvSpPr>
-          <p:cNvPr id="118" name="Shape 116"/>
-          <p:cNvSpPr/>
-          <p:nvPr/>
-        </p:nvSpPr>
-        <p:spPr>
-          <a:xfrm>
-            <a:off x="15361920" y="5971032"/>
-            <a:ext cx="2697480" cy="1188720"/>
+          <p:cNvPr id="124" name="Shape 122"/>
+          <p:cNvSpPr/>
+          <p:nvPr/>
+        </p:nvSpPr>
+        <p:spPr>
+          <a:xfrm>
+            <a:off x="14721840" y="5971032"/>
+            <a:ext cx="3291840" cy="1307592"/>
           </a:xfrm>
           <a:prstGeom prst="rect">
             <a:avLst/>
@@ -5556,14 +5790,14 @@
       </p:sp>
       <p:sp>
         <p:nvSpPr>
-          <p:cNvPr id="119" name="Text 117"/>
-          <p:cNvSpPr/>
-          <p:nvPr/>
-        </p:nvSpPr>
-        <p:spPr>
-          <a:xfrm>
-            <a:off x="15416784" y="6007608"/>
-            <a:ext cx="2587752" cy="228600"/>
+          <p:cNvPr id="125" name="Text 123"/>
+          <p:cNvSpPr/>
+          <p:nvPr/>
+        </p:nvSpPr>
+        <p:spPr>
+          <a:xfrm>
+            <a:off x="14794992" y="6007608"/>
+            <a:ext cx="3145536" cy="237744"/>
           </a:xfrm>
           <a:prstGeom prst="rect">
             <a:avLst/>
@@ -5595,14 +5829,14 @@
       </p:sp>
       <p:sp>
         <p:nvSpPr>
-          <p:cNvPr id="120" name="Text 118"/>
-          <p:cNvSpPr/>
-          <p:nvPr/>
-        </p:nvSpPr>
-        <p:spPr>
-          <a:xfrm>
-            <a:off x="15416784" y="6217920"/>
-            <a:ext cx="2587752" cy="182880"/>
+          <p:cNvPr id="126" name="Text 124"/>
+          <p:cNvSpPr/>
+          <p:nvPr/>
+        </p:nvSpPr>
+        <p:spPr>
+          <a:xfrm>
+            <a:off x="14794992" y="6227064"/>
+            <a:ext cx="3145536" cy="182880"/>
           </a:xfrm>
           <a:prstGeom prst="rect">
             <a:avLst/>
@@ -5634,14 +5868,14 @@
       </p:sp>
       <p:sp>
         <p:nvSpPr>
-          <p:cNvPr id="121" name="Text 119"/>
-          <p:cNvSpPr/>
-          <p:nvPr/>
-        </p:nvSpPr>
-        <p:spPr>
-          <a:xfrm>
-            <a:off x="15416784" y="6428232"/>
-            <a:ext cx="2587752" cy="685800"/>
+          <p:cNvPr id="127" name="Text 125"/>
+          <p:cNvSpPr/>
+          <p:nvPr/>
+        </p:nvSpPr>
+        <p:spPr>
+          <a:xfrm>
+            <a:off x="14794992" y="6428232"/>
+            <a:ext cx="3145536" cy="804672"/>
           </a:xfrm>
           <a:prstGeom prst="rect">
             <a:avLst/>
@@ -5749,59 +5983,20 @@
       </p:sp>
       <p:sp>
         <p:nvSpPr>
-          <p:cNvPr id="122" name="Text 120"/>
-          <p:cNvSpPr/>
-          <p:nvPr/>
-        </p:nvSpPr>
-        <p:spPr>
-          <a:xfrm>
-            <a:off x="274320" y="7260336"/>
-            <a:ext cx="17739360" cy="274320"/>
-          </a:xfrm>
-          <a:prstGeom prst="rect">
-            <a:avLst/>
-          </a:prstGeom>
-          <a:noFill/>
-          <a:ln/>
-        </p:spPr>
-        <p:txBody>
-          <a:bodyPr wrap="square" rtlCol="0" anchor="ctr"/>
-          <a:lstStyle/>
-          <a:p>
-            <a:pPr algn="ctr" indent="0" marL="0">
-              <a:buNone/>
-            </a:pPr>
-            <a:r>
-              <a:rPr lang="en-US" sz="1300" b="1" dirty="0">
-                <a:solidFill>
-                  <a:srgbClr val="0E2C66"/>
-                </a:solidFill>
-                <a:latin typeface="Calibri" pitchFamily="34" charset="0"/>
-                <a:ea typeface="Calibri" pitchFamily="34" charset="-122"/>
-                <a:cs typeface="Calibri" pitchFamily="34" charset="-120"/>
-              </a:rPr>
-              <a:t>FINANCIAL SUMMARY</a:t>
-            </a:r>
-            <a:endParaRPr lang="en-US" sz="1300" dirty="0"/>
-          </a:p>
-        </p:txBody>
-      </p:sp>
-      <p:sp>
-        <p:nvSpPr>
-          <p:cNvPr id="123" name="Shape 121"/>
-          <p:cNvSpPr/>
-          <p:nvPr/>
-        </p:nvSpPr>
-        <p:spPr>
-          <a:xfrm>
-            <a:off x="274320" y="7580376"/>
-            <a:ext cx="4229100" cy="777240"/>
-          </a:xfrm>
-          <a:prstGeom prst="rect">
-            <a:avLst/>
-          </a:prstGeom>
-          <a:solidFill>
-            <a:srgbClr val="F3F4F6"/>
+          <p:cNvPr id="128" name="Shape 126"/>
+          <p:cNvSpPr/>
+          <p:nvPr/>
+        </p:nvSpPr>
+        <p:spPr>
+          <a:xfrm>
+            <a:off x="274320" y="7461504"/>
+            <a:ext cx="8778240" cy="292608"/>
+          </a:xfrm>
+          <a:prstGeom prst="rect">
+            <a:avLst/>
+          </a:prstGeom>
+          <a:solidFill>
+            <a:srgbClr val="0E2C66"/>
           </a:solidFill>
           <a:ln w="12700">
             <a:solidFill>
@@ -5813,14 +6008,14 @@
       </p:sp>
       <p:sp>
         <p:nvSpPr>
-          <p:cNvPr id="124" name="Text 122"/>
-          <p:cNvSpPr/>
-          <p:nvPr/>
-        </p:nvSpPr>
-        <p:spPr>
-          <a:xfrm>
-            <a:off x="329184" y="7626096"/>
-            <a:ext cx="4119372" cy="713232"/>
+          <p:cNvPr id="129" name="Text 127"/>
+          <p:cNvSpPr/>
+          <p:nvPr/>
+        </p:nvSpPr>
+        <p:spPr>
+          <a:xfrm>
+            <a:off x="274320" y="7461504"/>
+            <a:ext cx="8778240" cy="292608"/>
           </a:xfrm>
           <a:prstGeom prst="rect">
             <a:avLst/>
@@ -5836,70 +6031,36 @@
               <a:buNone/>
             </a:pPr>
             <a:r>
-              <a:rPr lang="en-US" sz="900" b="1" dirty="0">
-                <a:solidFill>
-                  <a:srgbClr val="0E2C66"/>
-                </a:solidFill>
-                <a:latin typeface="Calibri" pitchFamily="34" charset="0"/>
-                <a:ea typeface="Calibri" pitchFamily="34" charset="-122"/>
-                <a:cs typeface="Calibri" pitchFamily="34" charset="-120"/>
-              </a:rPr>
-              <a:t>Total Spent</a:t>
-            </a:r>
-            <a:endParaRPr lang="en-US" sz="900" dirty="0"/>
-          </a:p>
-          <a:p>
-            <a:pPr algn="ctr" indent="0" marL="0">
-              <a:buNone/>
-            </a:pPr>
-            <a:r>
-              <a:rPr lang="en-US" sz="1400" b="1" dirty="0">
-                <a:solidFill>
-                  <a:srgbClr val="111827"/>
-                </a:solidFill>
-                <a:latin typeface="Calibri" pitchFamily="34" charset="0"/>
-                <a:ea typeface="Calibri" pitchFamily="34" charset="-122"/>
-                <a:cs typeface="Calibri" pitchFamily="34" charset="-120"/>
-              </a:rPr>
-              <a:t>~$20,000</a:t>
-            </a:r>
-            <a:endParaRPr lang="en-US" sz="900" dirty="0"/>
-          </a:p>
-          <a:p>
-            <a:pPr algn="ctr" indent="0" marL="0">
-              <a:buNone/>
-            </a:pPr>
-            <a:r>
-              <a:rPr lang="en-US" sz="800" i="1" dirty="0">
-                <a:solidFill>
-                  <a:srgbClr val="4B5563"/>
-                </a:solidFill>
-                <a:latin typeface="Calibri" pitchFamily="34" charset="0"/>
-                <a:ea typeface="Calibri" pitchFamily="34" charset="-122"/>
-                <a:cs typeface="Calibri" pitchFamily="34" charset="-120"/>
-              </a:rPr>
-              <a:t>(Jan – Apr 2026)</a:t>
-            </a:r>
-            <a:endParaRPr lang="en-US" sz="900" dirty="0"/>
-          </a:p>
-        </p:txBody>
-      </p:sp>
-      <p:sp>
-        <p:nvSpPr>
-          <p:cNvPr id="125" name="Shape 123"/>
-          <p:cNvSpPr/>
-          <p:nvPr/>
-        </p:nvSpPr>
-        <p:spPr>
-          <a:xfrm>
-            <a:off x="4777740" y="7580376"/>
-            <a:ext cx="4229100" cy="777240"/>
-          </a:xfrm>
-          <a:prstGeom prst="rect">
-            <a:avLst/>
-          </a:prstGeom>
-          <a:solidFill>
-            <a:srgbClr val="F3F4F6"/>
+              <a:rPr lang="en-US" sz="1200" b="1" dirty="0">
+                <a:solidFill>
+                  <a:srgbClr val="FFFFFF"/>
+                </a:solidFill>
+                <a:latin typeface="Calibri" pitchFamily="34" charset="0"/>
+                <a:ea typeface="Calibri" pitchFamily="34" charset="-122"/>
+                <a:cs typeface="Calibri" pitchFamily="34" charset="-120"/>
+              </a:rPr>
+              <a:t>FINANCIAL SUMMARY</a:t>
+            </a:r>
+            <a:endParaRPr lang="en-US" sz="1200" dirty="0"/>
+          </a:p>
+        </p:txBody>
+      </p:sp>
+      <p:sp>
+        <p:nvSpPr>
+          <p:cNvPr id="130" name="Shape 128"/>
+          <p:cNvSpPr/>
+          <p:nvPr/>
+        </p:nvSpPr>
+        <p:spPr>
+          <a:xfrm>
+            <a:off x="9235440" y="7461504"/>
+            <a:ext cx="8778240" cy="292608"/>
+          </a:xfrm>
+          <a:prstGeom prst="rect">
+            <a:avLst/>
+          </a:prstGeom>
+          <a:solidFill>
+            <a:srgbClr val="0E2C66"/>
           </a:solidFill>
           <a:ln w="12700">
             <a:solidFill>
@@ -5911,14 +6072,14 @@
       </p:sp>
       <p:sp>
         <p:nvSpPr>
-          <p:cNvPr id="126" name="Text 124"/>
-          <p:cNvSpPr/>
-          <p:nvPr/>
-        </p:nvSpPr>
-        <p:spPr>
-          <a:xfrm>
-            <a:off x="4832604" y="7626096"/>
-            <a:ext cx="4119372" cy="713232"/>
+          <p:cNvPr id="131" name="Text 129"/>
+          <p:cNvSpPr/>
+          <p:nvPr/>
+        </p:nvSpPr>
+        <p:spPr>
+          <a:xfrm>
+            <a:off x="9235440" y="7461504"/>
+            <a:ext cx="8778240" cy="292608"/>
           </a:xfrm>
           <a:prstGeom prst="rect">
             <a:avLst/>
@@ -5934,70 +6095,36 @@
               <a:buNone/>
             </a:pPr>
             <a:r>
-              <a:rPr lang="en-US" sz="900" b="1" dirty="0">
-                <a:solidFill>
-                  <a:srgbClr val="0E2C66"/>
-                </a:solidFill>
-                <a:latin typeface="Calibri" pitchFamily="34" charset="0"/>
-                <a:ea typeface="Calibri" pitchFamily="34" charset="-122"/>
-                <a:cs typeface="Calibri" pitchFamily="34" charset="-120"/>
-              </a:rPr>
-              <a:t>Estimated Wasted / Redundant Charges</a:t>
-            </a:r>
-            <a:endParaRPr lang="en-US" sz="900" dirty="0"/>
-          </a:p>
-          <a:p>
-            <a:pPr algn="ctr" indent="0" marL="0">
-              <a:buNone/>
-            </a:pPr>
-            <a:r>
-              <a:rPr lang="en-US" sz="1400" b="1" dirty="0">
-                <a:solidFill>
-                  <a:srgbClr val="111827"/>
-                </a:solidFill>
-                <a:latin typeface="Calibri" pitchFamily="34" charset="0"/>
-                <a:ea typeface="Calibri" pitchFamily="34" charset="-122"/>
-                <a:cs typeface="Calibri" pitchFamily="34" charset="-120"/>
-              </a:rPr>
-              <a:t>~$10,000</a:t>
-            </a:r>
-            <a:endParaRPr lang="en-US" sz="900" dirty="0"/>
-          </a:p>
-          <a:p>
-            <a:pPr algn="ctr" indent="0" marL="0">
-              <a:buNone/>
-            </a:pPr>
-            <a:r>
-              <a:rPr lang="en-US" sz="800" i="1" dirty="0">
-                <a:solidFill>
-                  <a:srgbClr val="4B5563"/>
-                </a:solidFill>
-                <a:latin typeface="Calibri" pitchFamily="34" charset="0"/>
-                <a:ea typeface="Calibri" pitchFamily="34" charset="-122"/>
-                <a:cs typeface="Calibri" pitchFamily="34" charset="-120"/>
-              </a:rPr>
-              <a:t>(Approx. 50% of total spend)</a:t>
-            </a:r>
-            <a:endParaRPr lang="en-US" sz="900" dirty="0"/>
-          </a:p>
-        </p:txBody>
-      </p:sp>
-      <p:sp>
-        <p:nvSpPr>
-          <p:cNvPr id="127" name="Shape 125"/>
-          <p:cNvSpPr/>
-          <p:nvPr/>
-        </p:nvSpPr>
-        <p:spPr>
-          <a:xfrm>
-            <a:off x="9281160" y="7580376"/>
-            <a:ext cx="4229100" cy="777240"/>
-          </a:xfrm>
-          <a:prstGeom prst="rect">
-            <a:avLst/>
-          </a:prstGeom>
-          <a:solidFill>
-            <a:srgbClr val="F3F4F6"/>
+              <a:rPr lang="en-US" sz="1200" b="1" dirty="0">
+                <a:solidFill>
+                  <a:srgbClr val="FFFFFF"/>
+                </a:solidFill>
+                <a:latin typeface="Calibri" pitchFamily="34" charset="0"/>
+                <a:ea typeface="Calibri" pitchFamily="34" charset="-122"/>
+                <a:cs typeface="Calibri" pitchFamily="34" charset="-120"/>
+              </a:rPr>
+              <a:t>KEY LEGAL &amp; CONSUMER REFERENCE POINTS</a:t>
+            </a:r>
+            <a:endParaRPr lang="en-US" sz="1200" dirty="0"/>
+          </a:p>
+        </p:txBody>
+      </p:sp>
+      <p:sp>
+        <p:nvSpPr>
+          <p:cNvPr id="132" name="Shape 130"/>
+          <p:cNvSpPr/>
+          <p:nvPr/>
+        </p:nvSpPr>
+        <p:spPr>
+          <a:xfrm>
+            <a:off x="320040" y="7827264"/>
+            <a:ext cx="2865120" cy="914400"/>
+          </a:xfrm>
+          <a:prstGeom prst="rect">
+            <a:avLst/>
+          </a:prstGeom>
+          <a:solidFill>
+            <a:srgbClr val="FFFFFF"/>
           </a:solidFill>
           <a:ln w="12700">
             <a:solidFill>
@@ -6009,14 +6136,39 @@
       </p:sp>
       <p:sp>
         <p:nvSpPr>
-          <p:cNvPr id="128" name="Text 126"/>
-          <p:cNvSpPr/>
-          <p:nvPr/>
-        </p:nvSpPr>
-        <p:spPr>
-          <a:xfrm>
-            <a:off x="9336024" y="7626096"/>
-            <a:ext cx="4119372" cy="713232"/>
+          <p:cNvPr id="133" name="Shape 131"/>
+          <p:cNvSpPr/>
+          <p:nvPr/>
+        </p:nvSpPr>
+        <p:spPr>
+          <a:xfrm>
+            <a:off x="411480" y="8083296"/>
+            <a:ext cx="402336" cy="402336"/>
+          </a:xfrm>
+          <a:prstGeom prst="ellipse">
+            <a:avLst/>
+          </a:prstGeom>
+          <a:solidFill>
+            <a:srgbClr val="16A34A"/>
+          </a:solidFill>
+          <a:ln w="12700">
+            <a:solidFill>
+              <a:srgbClr val="16A34A"/>
+            </a:solidFill>
+            <a:prstDash val="solid"/>
+          </a:ln>
+        </p:spPr>
+      </p:sp>
+      <p:sp>
+        <p:nvSpPr>
+          <p:cNvPr id="134" name="Text 132"/>
+          <p:cNvSpPr/>
+          <p:nvPr/>
+        </p:nvSpPr>
+        <p:spPr>
+          <a:xfrm>
+            <a:off x="411480" y="8083296"/>
+            <a:ext cx="402336" cy="402336"/>
           </a:xfrm>
           <a:prstGeom prst="rect">
             <a:avLst/>
@@ -6032,6 +6184,45 @@
               <a:buNone/>
             </a:pPr>
             <a:r>
+              <a:rPr lang="en-US" sz="1800" b="1" dirty="0">
+                <a:solidFill>
+                  <a:srgbClr val="FFFFFF"/>
+                </a:solidFill>
+                <a:latin typeface="Calibri" pitchFamily="34" charset="0"/>
+                <a:ea typeface="Calibri" pitchFamily="34" charset="-122"/>
+                <a:cs typeface="Calibri" pitchFamily="34" charset="-120"/>
+              </a:rPr>
+              <a:t>$</a:t>
+            </a:r>
+            <a:endParaRPr lang="en-US" sz="1800" dirty="0"/>
+          </a:p>
+        </p:txBody>
+      </p:sp>
+      <p:sp>
+        <p:nvSpPr>
+          <p:cNvPr id="135" name="Text 133"/>
+          <p:cNvSpPr/>
+          <p:nvPr/>
+        </p:nvSpPr>
+        <p:spPr>
+          <a:xfrm>
+            <a:off x="868680" y="7872984"/>
+            <a:ext cx="2270760" cy="822960"/>
+          </a:xfrm>
+          <a:prstGeom prst="rect">
+            <a:avLst/>
+          </a:prstGeom>
+          <a:noFill/>
+          <a:ln/>
+        </p:spPr>
+        <p:txBody>
+          <a:bodyPr wrap="square" rtlCol="0" anchor="ctr"/>
+          <a:lstStyle/>
+          <a:p>
+            <a:pPr algn="l" indent="0" marL="0">
+              <a:buNone/>
+            </a:pPr>
+            <a:r>
               <a:rPr lang="en-US" sz="900" b="1" dirty="0">
                 <a:solidFill>
                   <a:srgbClr val="0E2C66"/>
@@ -6040,16 +6231,16 @@
                 <a:ea typeface="Calibri" pitchFamily="34" charset="-122"/>
                 <a:cs typeface="Calibri" pitchFamily="34" charset="-120"/>
               </a:rPr>
-              <a:t>Reasonable Time to Complete</a:t>
+              <a:t>Total Spent</a:t>
             </a:r>
             <a:endParaRPr lang="en-US" sz="900" dirty="0"/>
           </a:p>
           <a:p>
-            <a:pPr algn="ctr" indent="0" marL="0">
-              <a:buNone/>
-            </a:pPr>
-            <a:r>
-              <a:rPr lang="en-US" sz="1400" b="1" dirty="0">
+            <a:pPr algn="l" indent="0" marL="0">
+              <a:buNone/>
+            </a:pPr>
+            <a:r>
+              <a:rPr lang="en-US" sz="1200" b="1" dirty="0">
                 <a:solidFill>
                   <a:srgbClr val="111827"/>
                 </a:solidFill>
@@ -6057,12 +6248,12 @@
                 <a:ea typeface="Calibri" pitchFamily="34" charset="-122"/>
                 <a:cs typeface="Calibri" pitchFamily="34" charset="-120"/>
               </a:rPr>
-              <a:t>25% – 50%</a:t>
+              <a:t>~$20,000</a:t>
             </a:r>
             <a:endParaRPr lang="en-US" sz="900" dirty="0"/>
           </a:p>
           <a:p>
-            <a:pPr algn="ctr" indent="0" marL="0">
+            <a:pPr algn="l" indent="0" marL="0">
               <a:buNone/>
             </a:pPr>
             <a:r>
@@ -6074,7 +6265,7 @@
                 <a:ea typeface="Calibri" pitchFamily="34" charset="-122"/>
                 <a:cs typeface="Calibri" pitchFamily="34" charset="-120"/>
               </a:rPr>
-              <a:t>of actual time and cost</a:t>
+              <a:t>(Jan – Apr 2026)</a:t>
             </a:r>
             <a:endParaRPr lang="en-US" sz="900" dirty="0"/>
           </a:p>
@@ -6082,20 +6273,20 @@
       </p:sp>
       <p:sp>
         <p:nvSpPr>
-          <p:cNvPr id="129" name="Shape 127"/>
-          <p:cNvSpPr/>
-          <p:nvPr/>
-        </p:nvSpPr>
-        <p:spPr>
-          <a:xfrm>
-            <a:off x="13784580" y="7580376"/>
-            <a:ext cx="4229100" cy="777240"/>
-          </a:xfrm>
-          <a:prstGeom prst="rect">
-            <a:avLst/>
-          </a:prstGeom>
-          <a:solidFill>
-            <a:srgbClr val="F3F4F6"/>
+          <p:cNvPr id="136" name="Shape 134"/>
+          <p:cNvSpPr/>
+          <p:nvPr/>
+        </p:nvSpPr>
+        <p:spPr>
+          <a:xfrm>
+            <a:off x="3230880" y="7827264"/>
+            <a:ext cx="2865120" cy="914400"/>
+          </a:xfrm>
+          <a:prstGeom prst="rect">
+            <a:avLst/>
+          </a:prstGeom>
+          <a:solidFill>
+            <a:srgbClr val="FFFFFF"/>
           </a:solidFill>
           <a:ln w="12700">
             <a:solidFill>
@@ -6107,14 +6298,39 @@
       </p:sp>
       <p:sp>
         <p:nvSpPr>
-          <p:cNvPr id="130" name="Text 128"/>
-          <p:cNvSpPr/>
-          <p:nvPr/>
-        </p:nvSpPr>
-        <p:spPr>
-          <a:xfrm>
-            <a:off x="13839444" y="7626096"/>
-            <a:ext cx="4119372" cy="713232"/>
+          <p:cNvPr id="137" name="Shape 135"/>
+          <p:cNvSpPr/>
+          <p:nvPr/>
+        </p:nvSpPr>
+        <p:spPr>
+          <a:xfrm>
+            <a:off x="3322320" y="8083296"/>
+            <a:ext cx="402336" cy="402336"/>
+          </a:xfrm>
+          <a:prstGeom prst="ellipse">
+            <a:avLst/>
+          </a:prstGeom>
+          <a:solidFill>
+            <a:srgbClr val="EA580C"/>
+          </a:solidFill>
+          <a:ln w="12700">
+            <a:solidFill>
+              <a:srgbClr val="EA580C"/>
+            </a:solidFill>
+            <a:prstDash val="solid"/>
+          </a:ln>
+        </p:spPr>
+      </p:sp>
+      <p:sp>
+        <p:nvSpPr>
+          <p:cNvPr id="138" name="Text 136"/>
+          <p:cNvSpPr/>
+          <p:nvPr/>
+        </p:nvSpPr>
+        <p:spPr>
+          <a:xfrm>
+            <a:off x="3322320" y="8083296"/>
+            <a:ext cx="402336" cy="402336"/>
           </a:xfrm>
           <a:prstGeom prst="rect">
             <a:avLst/>
@@ -6130,6 +6346,45 @@
               <a:buNone/>
             </a:pPr>
             <a:r>
+              <a:rPr lang="en-US" sz="1800" b="1" dirty="0">
+                <a:solidFill>
+                  <a:srgbClr val="FFFFFF"/>
+                </a:solidFill>
+                <a:latin typeface="Calibri" pitchFamily="34" charset="0"/>
+                <a:ea typeface="Calibri" pitchFamily="34" charset="-122"/>
+                <a:cs typeface="Calibri" pitchFamily="34" charset="-120"/>
+              </a:rPr>
+              <a:t>$</a:t>
+            </a:r>
+            <a:endParaRPr lang="en-US" sz="1800" dirty="0"/>
+          </a:p>
+        </p:txBody>
+      </p:sp>
+      <p:sp>
+        <p:nvSpPr>
+          <p:cNvPr id="139" name="Text 137"/>
+          <p:cNvSpPr/>
+          <p:nvPr/>
+        </p:nvSpPr>
+        <p:spPr>
+          <a:xfrm>
+            <a:off x="3779520" y="7872984"/>
+            <a:ext cx="2270760" cy="822960"/>
+          </a:xfrm>
+          <a:prstGeom prst="rect">
+            <a:avLst/>
+          </a:prstGeom>
+          <a:noFill/>
+          <a:ln/>
+        </p:spPr>
+        <p:txBody>
+          <a:bodyPr wrap="square" rtlCol="0" anchor="ctr"/>
+          <a:lstStyle/>
+          <a:p>
+            <a:pPr algn="l" indent="0" marL="0">
+              <a:buNone/>
+            </a:pPr>
+            <a:r>
               <a:rPr lang="en-US" sz="900" b="1" dirty="0">
                 <a:solidFill>
                   <a:srgbClr val="0E2C66"/>
@@ -6138,16 +6393,178 @@
                 <a:ea typeface="Calibri" pitchFamily="34" charset="-122"/>
                 <a:cs typeface="Calibri" pitchFamily="34" charset="-120"/>
               </a:rPr>
-              <a:t>Status</a:t>
+              <a:t>Estimated Wasted / Redundant Charges</a:t>
             </a:r>
             <a:endParaRPr lang="en-US" sz="900" dirty="0"/>
           </a:p>
           <a:p>
+            <a:pPr algn="l" indent="0" marL="0">
+              <a:buNone/>
+            </a:pPr>
+            <a:r>
+              <a:rPr lang="en-US" sz="1200" b="1" dirty="0">
+                <a:solidFill>
+                  <a:srgbClr val="111827"/>
+                </a:solidFill>
+                <a:latin typeface="Calibri" pitchFamily="34" charset="0"/>
+                <a:ea typeface="Calibri" pitchFamily="34" charset="-122"/>
+                <a:cs typeface="Calibri" pitchFamily="34" charset="-120"/>
+              </a:rPr>
+              <a:t>~$10,000</a:t>
+            </a:r>
+            <a:endParaRPr lang="en-US" sz="900" dirty="0"/>
+          </a:p>
+          <a:p>
+            <a:pPr algn="l" indent="0" marL="0">
+              <a:buNone/>
+            </a:pPr>
+            <a:r>
+              <a:rPr lang="en-US" sz="800" i="1" dirty="0">
+                <a:solidFill>
+                  <a:srgbClr val="4B5563"/>
+                </a:solidFill>
+                <a:latin typeface="Calibri" pitchFamily="34" charset="0"/>
+                <a:ea typeface="Calibri" pitchFamily="34" charset="-122"/>
+                <a:cs typeface="Calibri" pitchFamily="34" charset="-120"/>
+              </a:rPr>
+              <a:t>(Approx. 50% of total spend)</a:t>
+            </a:r>
+            <a:endParaRPr lang="en-US" sz="900" dirty="0"/>
+          </a:p>
+        </p:txBody>
+      </p:sp>
+      <p:sp>
+        <p:nvSpPr>
+          <p:cNvPr id="140" name="Shape 138"/>
+          <p:cNvSpPr/>
+          <p:nvPr/>
+        </p:nvSpPr>
+        <p:spPr>
+          <a:xfrm>
+            <a:off x="6141720" y="7827264"/>
+            <a:ext cx="2865120" cy="914400"/>
+          </a:xfrm>
+          <a:prstGeom prst="rect">
+            <a:avLst/>
+          </a:prstGeom>
+          <a:solidFill>
+            <a:srgbClr val="FFFFFF"/>
+          </a:solidFill>
+          <a:ln w="12700">
+            <a:solidFill>
+              <a:srgbClr val="0E2C66"/>
+            </a:solidFill>
+            <a:prstDash val="solid"/>
+          </a:ln>
+        </p:spPr>
+      </p:sp>
+      <p:sp>
+        <p:nvSpPr>
+          <p:cNvPr id="141" name="Shape 139"/>
+          <p:cNvSpPr/>
+          <p:nvPr/>
+        </p:nvSpPr>
+        <p:spPr>
+          <a:xfrm>
+            <a:off x="6233160" y="8083296"/>
+            <a:ext cx="402336" cy="402336"/>
+          </a:xfrm>
+          <a:prstGeom prst="ellipse">
+            <a:avLst/>
+          </a:prstGeom>
+          <a:solidFill>
+            <a:srgbClr val="0E2C66"/>
+          </a:solidFill>
+          <a:ln w="12700">
+            <a:solidFill>
+              <a:srgbClr val="0E2C66"/>
+            </a:solidFill>
+            <a:prstDash val="solid"/>
+          </a:ln>
+        </p:spPr>
+      </p:sp>
+      <p:sp>
+        <p:nvSpPr>
+          <p:cNvPr id="142" name="Text 140"/>
+          <p:cNvSpPr/>
+          <p:nvPr/>
+        </p:nvSpPr>
+        <p:spPr>
+          <a:xfrm>
+            <a:off x="6233160" y="8083296"/>
+            <a:ext cx="402336" cy="402336"/>
+          </a:xfrm>
+          <a:prstGeom prst="rect">
+            <a:avLst/>
+          </a:prstGeom>
+          <a:noFill/>
+          <a:ln/>
+        </p:spPr>
+        <p:txBody>
+          <a:bodyPr wrap="square" rtlCol="0" anchor="ctr"/>
+          <a:lstStyle/>
+          <a:p>
             <a:pPr algn="ctr" indent="0" marL="0">
               <a:buNone/>
             </a:pPr>
             <a:r>
-              <a:rPr lang="en-US" sz="1400" b="1" dirty="0">
+              <a:rPr lang="en-US" sz="1800" b="1" dirty="0">
+                <a:solidFill>
+                  <a:srgbClr val="FFFFFF"/>
+                </a:solidFill>
+                <a:latin typeface="Calibri" pitchFamily="34" charset="0"/>
+                <a:ea typeface="Calibri" pitchFamily="34" charset="-122"/>
+                <a:cs typeface="Calibri" pitchFamily="34" charset="-120"/>
+              </a:rPr>
+              <a:t>⏱</a:t>
+            </a:r>
+            <a:endParaRPr lang="en-US" sz="1800" dirty="0"/>
+          </a:p>
+        </p:txBody>
+      </p:sp>
+      <p:sp>
+        <p:nvSpPr>
+          <p:cNvPr id="143" name="Text 141"/>
+          <p:cNvSpPr/>
+          <p:nvPr/>
+        </p:nvSpPr>
+        <p:spPr>
+          <a:xfrm>
+            <a:off x="6690360" y="7872984"/>
+            <a:ext cx="2270760" cy="822960"/>
+          </a:xfrm>
+          <a:prstGeom prst="rect">
+            <a:avLst/>
+          </a:prstGeom>
+          <a:noFill/>
+          <a:ln/>
+        </p:spPr>
+        <p:txBody>
+          <a:bodyPr wrap="square" rtlCol="0" anchor="ctr"/>
+          <a:lstStyle/>
+          <a:p>
+            <a:pPr algn="l" indent="0" marL="0">
+              <a:buNone/>
+            </a:pPr>
+            <a:r>
+              <a:rPr lang="en-US" sz="900" b="1" dirty="0">
+                <a:solidFill>
+                  <a:srgbClr val="0E2C66"/>
+                </a:solidFill>
+                <a:latin typeface="Calibri" pitchFamily="34" charset="0"/>
+                <a:ea typeface="Calibri" pitchFamily="34" charset="-122"/>
+                <a:cs typeface="Calibri" pitchFamily="34" charset="-120"/>
+              </a:rPr>
+              <a:t>Reasonable Time to Complete</a:t>
+            </a:r>
+            <a:endParaRPr lang="en-US" sz="900" dirty="0"/>
+          </a:p>
+          <a:p>
+            <a:pPr algn="l" indent="0" marL="0">
+              <a:buNone/>
+            </a:pPr>
+            <a:r>
+              <a:rPr lang="en-US" sz="1200" b="1" dirty="0">
                 <a:solidFill>
                   <a:srgbClr val="111827"/>
                 </a:solidFill>
@@ -6155,12 +6572,12 @@
                 <a:ea typeface="Calibri" pitchFamily="34" charset="-122"/>
                 <a:cs typeface="Calibri" pitchFamily="34" charset="-120"/>
               </a:rPr>
-              <a:t>Unresolved</a:t>
+              <a:t>Should have taken 25% – 50%</a:t>
             </a:r>
             <a:endParaRPr lang="en-US" sz="900" dirty="0"/>
           </a:p>
           <a:p>
-            <a:pPr algn="ctr" indent="0" marL="0">
+            <a:pPr algn="l" indent="0" marL="0">
               <a:buNone/>
             </a:pPr>
             <a:r>
@@ -6172,7 +6589,7 @@
                 <a:ea typeface="Calibri" pitchFamily="34" charset="-122"/>
                 <a:cs typeface="Calibri" pitchFamily="34" charset="-120"/>
               </a:rPr>
-              <a:t>as of late April 2026</a:t>
+              <a:t>of actual time and cost</a:t>
             </a:r>
             <a:endParaRPr lang="en-US" sz="900" dirty="0"/>
           </a:p>
@@ -6180,14 +6597,14 @@
       </p:sp>
       <p:sp>
         <p:nvSpPr>
-          <p:cNvPr id="131" name="Text 129"/>
-          <p:cNvSpPr/>
-          <p:nvPr/>
-        </p:nvSpPr>
-        <p:spPr>
-          <a:xfrm>
-            <a:off x="274320" y="8494776"/>
-            <a:ext cx="17739360" cy="274320"/>
+          <p:cNvPr id="144" name="Text 142"/>
+          <p:cNvSpPr/>
+          <p:nvPr/>
+        </p:nvSpPr>
+        <p:spPr>
+          <a:xfrm>
+            <a:off x="9281160" y="7827264"/>
+            <a:ext cx="4297680" cy="289560"/>
           </a:xfrm>
           <a:prstGeom prst="rect">
             <a:avLst/>
@@ -6199,34 +6616,48 @@
           <a:bodyPr wrap="square" rtlCol="0" anchor="ctr"/>
           <a:lstStyle/>
           <a:p>
-            <a:pPr algn="ctr" indent="0" marL="0">
-              <a:buNone/>
-            </a:pPr>
-            <a:r>
-              <a:rPr lang="en-US" sz="1300" b="1" dirty="0">
-                <a:solidFill>
-                  <a:srgbClr val="0E2C66"/>
-                </a:solidFill>
-                <a:latin typeface="Calibri" pitchFamily="34" charset="0"/>
-                <a:ea typeface="Calibri" pitchFamily="34" charset="-122"/>
-                <a:cs typeface="Calibri" pitchFamily="34" charset="-120"/>
-              </a:rPr>
-              <a:t>KEY LEGAL &amp; CONSUMER REFERENCE POINTS</a:t>
-            </a:r>
-            <a:endParaRPr lang="en-US" sz="1300" dirty="0"/>
-          </a:p>
-        </p:txBody>
-      </p:sp>
-      <p:sp>
-        <p:nvSpPr>
-          <p:cNvPr id="132" name="Text 130"/>
-          <p:cNvSpPr/>
-          <p:nvPr/>
-        </p:nvSpPr>
-        <p:spPr>
-          <a:xfrm>
-            <a:off x="274320" y="8823960"/>
-            <a:ext cx="5730240" cy="329184"/>
+            <a:pPr indent="0" marL="0">
+              <a:buNone/>
+            </a:pPr>
+            <a:r>
+              <a:rPr lang="en-US" sz="1000" b="1" dirty="0">
+                <a:solidFill>
+                  <a:srgbClr val="16A34A"/>
+                </a:solidFill>
+                <a:latin typeface="Calibri" pitchFamily="34" charset="0"/>
+                <a:ea typeface="Calibri" pitchFamily="34" charset="-122"/>
+                <a:cs typeface="Calibri" pitchFamily="34" charset="-120"/>
+              </a:rPr>
+              <a:t>✓  </a:t>
+            </a:r>
+            <a:pPr indent="0" marL="0">
+              <a:buNone/>
+            </a:pPr>
+            <a:r>
+              <a:rPr lang="en-US" sz="1000" dirty="0">
+                <a:solidFill>
+                  <a:srgbClr val="111827"/>
+                </a:solidFill>
+                <a:latin typeface="Calibri" pitchFamily="34" charset="0"/>
+                <a:ea typeface="Calibri" pitchFamily="34" charset="-122"/>
+                <a:cs typeface="Calibri" pitchFamily="34" charset="-120"/>
+              </a:rPr>
+              <a:t>Misrepresentation of log availability (relied upon)</a:t>
+            </a:r>
+            <a:endParaRPr lang="en-US" sz="1000" dirty="0"/>
+          </a:p>
+        </p:txBody>
+      </p:sp>
+      <p:sp>
+        <p:nvSpPr>
+          <p:cNvPr id="145" name="Text 143"/>
+          <p:cNvSpPr/>
+          <p:nvPr/>
+        </p:nvSpPr>
+        <p:spPr>
+          <a:xfrm>
+            <a:off x="9281160" y="8116824"/>
+            <a:ext cx="4297680" cy="289560"/>
           </a:xfrm>
           <a:prstGeom prst="rect">
             <a:avLst/>
@@ -6244,13 +6675,13 @@
             <a:r>
               <a:rPr lang="en-US" sz="1000" b="1" dirty="0">
                 <a:solidFill>
-                  <a:srgbClr val="0E2C66"/>
-                </a:solidFill>
-                <a:latin typeface="Calibri" pitchFamily="34" charset="0"/>
-                <a:ea typeface="Calibri" pitchFamily="34" charset="-122"/>
-                <a:cs typeface="Calibri" pitchFamily="34" charset="-120"/>
-              </a:rPr>
-              <a:t>•  </a:t>
+                  <a:srgbClr val="16A34A"/>
+                </a:solidFill>
+                <a:latin typeface="Calibri" pitchFamily="34" charset="0"/>
+                <a:ea typeface="Calibri" pitchFamily="34" charset="-122"/>
+                <a:cs typeface="Calibri" pitchFamily="34" charset="-120"/>
+              </a:rPr>
+              <a:t>✓  </a:t>
             </a:r>
             <a:pPr indent="0" marL="0">
               <a:buNone/>
@@ -6264,7 +6695,7 @@
                 <a:ea typeface="Calibri" pitchFamily="34" charset="-122"/>
                 <a:cs typeface="Calibri" pitchFamily="34" charset="-120"/>
               </a:rPr>
-              <a:t>Misrepresentation of log availability (relied upon)</a:t>
+              <a:t>False representation of work completion</a:t>
             </a:r>
             <a:endParaRPr lang="en-US" sz="1000" dirty="0"/>
           </a:p>
@@ -6272,14 +6703,14 @@
       </p:sp>
       <p:sp>
         <p:nvSpPr>
-          <p:cNvPr id="133" name="Text 131"/>
-          <p:cNvSpPr/>
-          <p:nvPr/>
-        </p:nvSpPr>
-        <p:spPr>
-          <a:xfrm>
-            <a:off x="6278880" y="8823960"/>
-            <a:ext cx="5730240" cy="329184"/>
+          <p:cNvPr id="146" name="Text 144"/>
+          <p:cNvSpPr/>
+          <p:nvPr/>
+        </p:nvSpPr>
+        <p:spPr>
+          <a:xfrm>
+            <a:off x="9281160" y="8406384"/>
+            <a:ext cx="4297680" cy="289560"/>
           </a:xfrm>
           <a:prstGeom prst="rect">
             <a:avLst/>
@@ -6297,13 +6728,13 @@
             <a:r>
               <a:rPr lang="en-US" sz="1000" b="1" dirty="0">
                 <a:solidFill>
-                  <a:srgbClr val="0E2C66"/>
-                </a:solidFill>
-                <a:latin typeface="Calibri" pitchFamily="34" charset="0"/>
-                <a:ea typeface="Calibri" pitchFamily="34" charset="-122"/>
-                <a:cs typeface="Calibri" pitchFamily="34" charset="-120"/>
-              </a:rPr>
-              <a:t>•  </a:t>
+                  <a:srgbClr val="16A34A"/>
+                </a:solidFill>
+                <a:latin typeface="Calibri" pitchFamily="34" charset="0"/>
+                <a:ea typeface="Calibri" pitchFamily="34" charset="-122"/>
+                <a:cs typeface="Calibri" pitchFamily="34" charset="-120"/>
+              </a:rPr>
+              <a:t>✓  </a:t>
             </a:r>
             <a:pPr indent="0" marL="0">
               <a:buNone/>
@@ -6317,7 +6748,7 @@
                 <a:ea typeface="Calibri" pitchFamily="34" charset="-122"/>
                 <a:cs typeface="Calibri" pitchFamily="34" charset="-120"/>
               </a:rPr>
-              <a:t>False representation of work completion</a:t>
+              <a:t>Unfair and unconscionable charges</a:t>
             </a:r>
             <a:endParaRPr lang="en-US" sz="1000" dirty="0"/>
           </a:p>
@@ -6325,14 +6756,14 @@
       </p:sp>
       <p:sp>
         <p:nvSpPr>
-          <p:cNvPr id="134" name="Text 132"/>
-          <p:cNvSpPr/>
-          <p:nvPr/>
-        </p:nvSpPr>
-        <p:spPr>
-          <a:xfrm>
-            <a:off x="12283440" y="8823960"/>
-            <a:ext cx="5730240" cy="329184"/>
+          <p:cNvPr id="147" name="Text 145"/>
+          <p:cNvSpPr/>
+          <p:nvPr/>
+        </p:nvSpPr>
+        <p:spPr>
+          <a:xfrm>
+            <a:off x="13624560" y="7827264"/>
+            <a:ext cx="4297680" cy="289560"/>
           </a:xfrm>
           <a:prstGeom prst="rect">
             <a:avLst/>
@@ -6350,13 +6781,13 @@
             <a:r>
               <a:rPr lang="en-US" sz="1000" b="1" dirty="0">
                 <a:solidFill>
-                  <a:srgbClr val="0E2C66"/>
-                </a:solidFill>
-                <a:latin typeface="Calibri" pitchFamily="34" charset="0"/>
-                <a:ea typeface="Calibri" pitchFamily="34" charset="-122"/>
-                <a:cs typeface="Calibri" pitchFamily="34" charset="-120"/>
-              </a:rPr>
-              <a:t>•  </a:t>
+                  <a:srgbClr val="16A34A"/>
+                </a:solidFill>
+                <a:latin typeface="Calibri" pitchFamily="34" charset="0"/>
+                <a:ea typeface="Calibri" pitchFamily="34" charset="-122"/>
+                <a:cs typeface="Calibri" pitchFamily="34" charset="-120"/>
+              </a:rPr>
+              <a:t>✓  </a:t>
             </a:r>
             <a:pPr indent="0" marL="0">
               <a:buNone/>
@@ -6370,7 +6801,7 @@
                 <a:ea typeface="Calibri" pitchFamily="34" charset="-122"/>
                 <a:cs typeface="Calibri" pitchFamily="34" charset="-120"/>
               </a:rPr>
-              <a:t>Unfair and unconscionable charges</a:t>
+              <a:t>Failure to provide requested records</a:t>
             </a:r>
             <a:endParaRPr lang="en-US" sz="1000" dirty="0"/>
           </a:p>
@@ -6378,14 +6809,14 @@
       </p:sp>
       <p:sp>
         <p:nvSpPr>
-          <p:cNvPr id="135" name="Text 133"/>
-          <p:cNvSpPr/>
-          <p:nvPr/>
-        </p:nvSpPr>
-        <p:spPr>
-          <a:xfrm>
-            <a:off x="274320" y="9198864"/>
-            <a:ext cx="5730240" cy="329184"/>
+          <p:cNvPr id="148" name="Text 146"/>
+          <p:cNvSpPr/>
+          <p:nvPr/>
+        </p:nvSpPr>
+        <p:spPr>
+          <a:xfrm>
+            <a:off x="13624560" y="8116824"/>
+            <a:ext cx="4297680" cy="289560"/>
           </a:xfrm>
           <a:prstGeom prst="rect">
             <a:avLst/>
@@ -6403,13 +6834,13 @@
             <a:r>
               <a:rPr lang="en-US" sz="1000" b="1" dirty="0">
                 <a:solidFill>
-                  <a:srgbClr val="0E2C66"/>
-                </a:solidFill>
-                <a:latin typeface="Calibri" pitchFamily="34" charset="0"/>
-                <a:ea typeface="Calibri" pitchFamily="34" charset="-122"/>
-                <a:cs typeface="Calibri" pitchFamily="34" charset="-120"/>
-              </a:rPr>
-              <a:t>•  </a:t>
+                  <a:srgbClr val="16A34A"/>
+                </a:solidFill>
+                <a:latin typeface="Calibri" pitchFamily="34" charset="0"/>
+                <a:ea typeface="Calibri" pitchFamily="34" charset="-122"/>
+                <a:cs typeface="Calibri" pitchFamily="34" charset="-120"/>
+              </a:rPr>
+              <a:t>✓  </a:t>
             </a:r>
             <a:pPr indent="0" marL="0">
               <a:buNone/>
@@ -6423,7 +6854,7 @@
                 <a:ea typeface="Calibri" pitchFamily="34" charset="-122"/>
                 <a:cs typeface="Calibri" pitchFamily="34" charset="-120"/>
               </a:rPr>
-              <a:t>Failure to provide requested records</a:t>
+              <a:t>Premature dismissal of dispute</a:t>
             </a:r>
             <a:endParaRPr lang="en-US" sz="1000" dirty="0"/>
           </a:p>
@@ -6431,14 +6862,14 @@
       </p:sp>
       <p:sp>
         <p:nvSpPr>
-          <p:cNvPr id="136" name="Text 134"/>
-          <p:cNvSpPr/>
-          <p:nvPr/>
-        </p:nvSpPr>
-        <p:spPr>
-          <a:xfrm>
-            <a:off x="6278880" y="9198864"/>
-            <a:ext cx="5730240" cy="329184"/>
+          <p:cNvPr id="149" name="Text 147"/>
+          <p:cNvSpPr/>
+          <p:nvPr/>
+        </p:nvSpPr>
+        <p:spPr>
+          <a:xfrm>
+            <a:off x="13624560" y="8406384"/>
+            <a:ext cx="4297680" cy="289560"/>
           </a:xfrm>
           <a:prstGeom prst="rect">
             <a:avLst/>
@@ -6456,66 +6887,13 @@
             <a:r>
               <a:rPr lang="en-US" sz="1000" b="1" dirty="0">
                 <a:solidFill>
-                  <a:srgbClr val="0E2C66"/>
-                </a:solidFill>
-                <a:latin typeface="Calibri" pitchFamily="34" charset="0"/>
-                <a:ea typeface="Calibri" pitchFamily="34" charset="-122"/>
-                <a:cs typeface="Calibri" pitchFamily="34" charset="-120"/>
-              </a:rPr>
-              <a:t>•  </a:t>
-            </a:r>
-            <a:pPr indent="0" marL="0">
-              <a:buNone/>
-            </a:pPr>
-            <a:r>
-              <a:rPr lang="en-US" sz="1000" dirty="0">
-                <a:solidFill>
-                  <a:srgbClr val="111827"/>
-                </a:solidFill>
-                <a:latin typeface="Calibri" pitchFamily="34" charset="0"/>
-                <a:ea typeface="Calibri" pitchFamily="34" charset="-122"/>
-                <a:cs typeface="Calibri" pitchFamily="34" charset="-120"/>
-              </a:rPr>
-              <a:t>Premature dismissal of dispute</a:t>
-            </a:r>
-            <a:endParaRPr lang="en-US" sz="1000" dirty="0"/>
-          </a:p>
-        </p:txBody>
-      </p:sp>
-      <p:sp>
-        <p:nvSpPr>
-          <p:cNvPr id="137" name="Text 135"/>
-          <p:cNvSpPr/>
-          <p:nvPr/>
-        </p:nvSpPr>
-        <p:spPr>
-          <a:xfrm>
-            <a:off x="12283440" y="9198864"/>
-            <a:ext cx="5730240" cy="329184"/>
-          </a:xfrm>
-          <a:prstGeom prst="rect">
-            <a:avLst/>
-          </a:prstGeom>
-          <a:noFill/>
-          <a:ln/>
-        </p:spPr>
-        <p:txBody>
-          <a:bodyPr wrap="square" rtlCol="0" anchor="ctr"/>
-          <a:lstStyle/>
-          <a:p>
-            <a:pPr indent="0" marL="0">
-              <a:buNone/>
-            </a:pPr>
-            <a:r>
-              <a:rPr lang="en-US" sz="1000" b="1" dirty="0">
-                <a:solidFill>
-                  <a:srgbClr val="0E2C66"/>
-                </a:solidFill>
-                <a:latin typeface="Calibri" pitchFamily="34" charset="0"/>
-                <a:ea typeface="Calibri" pitchFamily="34" charset="-122"/>
-                <a:cs typeface="Calibri" pitchFamily="34" charset="-120"/>
-              </a:rPr>
-              <a:t>•  </a:t>
+                  <a:srgbClr val="16A34A"/>
+                </a:solidFill>
+                <a:latin typeface="Calibri" pitchFamily="34" charset="0"/>
+                <a:ea typeface="Calibri" pitchFamily="34" charset="-122"/>
+                <a:cs typeface="Calibri" pitchFamily="34" charset="-120"/>
+              </a:rPr>
+              <a:t>✓  </a:t>
             </a:r>
             <a:pPr indent="0" marL="0">
               <a:buNone/>

</xml_diff>